<commit_message>
fix(slides): fix slide-6 MCQ regression — relax char cap for options and question stems
Apply a higher char cap selectively for MCQ answer options (A–D) and question stems
(matched by pattern `Question \d+`) rather than for all list items:
- MCQ options: 200-char cap (option B was 156 chars, above the 120 general limit)
- Question stems: 220-char cap (question stem is 204 chars)
- Regular paragraphs and non-MCQ list items: unchanged 120-char cap

Also expand make_content_slide to render up to 5 bullets with adaptive spacing/font
(15pt, 0.95"/0.85" step/height) when a slide carries 5 items, so question + all 4
options fit on the KnowledgeCheck slide without overflowing the footer.

Fixes KOEA-7722 revision 2 regression: slide 6 now shows question stem + A/B/C/D.
Slides 2–5 content unchanged from revision 2.

Co-Authored-By: Paperclip <noreply@paperclip.ing>
</commit_message>
<xml_diff>
--- a/vault/courses/cursor-composer-2/03-cursor-cli-headless/slides.pptx
+++ b/vault/courses/cursor-composer-2/03-cursor-cli-headless/slides.pptx
@@ -3282,7 +3282,7 @@
         <p:spPr>
           <a:xfrm>
             <a:off x="731520" y="1600200"/>
-            <a:ext cx="10698480" cy="960120"/>
+            <a:ext cx="10698480" cy="777240"/>
           </a:xfrm>
           <a:prstGeom prst="rect">
             <a:avLst/>
@@ -3297,7 +3297,7 @@
           <a:p>
             <a:pPr algn="l"/>
             <a:r>
-              <a:rPr sz="1700" b="0">
+              <a:rPr sz="1500" b="0">
                 <a:solidFill>
                   <a:srgbClr val="FFFFFF"/>
                 </a:solidFill>
@@ -3315,8 +3315,8 @@
         </p:nvSpPr>
         <p:spPr>
           <a:xfrm>
-            <a:off x="731520" y="2651760"/>
-            <a:ext cx="10698480" cy="960120"/>
+            <a:off x="731520" y="2468880"/>
+            <a:ext cx="10698480" cy="777240"/>
           </a:xfrm>
           <a:prstGeom prst="rect">
             <a:avLst/>
@@ -3331,7 +3331,7 @@
           <a:p>
             <a:pPr algn="l"/>
             <a:r>
-              <a:rPr sz="1700" b="0">
+              <a:rPr sz="1500" b="0">
                 <a:solidFill>
                   <a:srgbClr val="FFFFFF"/>
                 </a:solidFill>
@@ -3349,8 +3349,8 @@
         </p:nvSpPr>
         <p:spPr>
           <a:xfrm>
-            <a:off x="731520" y="3703320"/>
-            <a:ext cx="10698480" cy="960120"/>
+            <a:off x="731520" y="3337560"/>
+            <a:ext cx="10698480" cy="777240"/>
           </a:xfrm>
           <a:prstGeom prst="rect">
             <a:avLst/>
@@ -3365,7 +3365,7 @@
           <a:p>
             <a:pPr algn="l"/>
             <a:r>
-              <a:rPr sz="1700" b="0">
+              <a:rPr sz="1500" b="0">
                 <a:solidFill>
                   <a:srgbClr val="FFFFFF"/>
                 </a:solidFill>
@@ -3383,8 +3383,8 @@
         </p:nvSpPr>
         <p:spPr>
           <a:xfrm>
-            <a:off x="731520" y="4754880"/>
-            <a:ext cx="10698480" cy="960120"/>
+            <a:off x="731520" y="4206240"/>
+            <a:ext cx="10698480" cy="777240"/>
           </a:xfrm>
           <a:prstGeom prst="rect">
             <a:avLst/>
@@ -3399,7 +3399,7 @@
           <a:p>
             <a:pPr algn="l"/>
             <a:r>
-              <a:rPr sz="1700" b="0">
+              <a:rPr sz="1500" b="0">
                 <a:solidFill>
                   <a:srgbClr val="FFFFFF"/>
                 </a:solidFill>
@@ -3412,6 +3412,40 @@
       <p:sp>
         <p:nvSpPr>
           <p:cNvPr id="8" name="TextBox 7"/>
+          <p:cNvSpPr txBox="1"/>
+          <p:nvPr/>
+        </p:nvSpPr>
+        <p:spPr>
+          <a:xfrm>
+            <a:off x="731520" y="5074920"/>
+            <a:ext cx="10698480" cy="777240"/>
+          </a:xfrm>
+          <a:prstGeom prst="rect">
+            <a:avLst/>
+          </a:prstGeom>
+          <a:noFill/>
+        </p:spPr>
+        <p:txBody>
+          <a:bodyPr wrap="square">
+            <a:spAutoFit/>
+          </a:bodyPr>
+          <a:lstStyle/>
+          <a:p>
+            <a:pPr algn="l"/>
+            <a:r>
+              <a:rPr sz="1500" b="0">
+                <a:solidFill>
+                  <a:srgbClr val="FFFFFF"/>
+                </a:solidFill>
+              </a:rPr>
+              <a:t>  What the boundary looks like in practice</a:t>
+            </a:r>
+          </a:p>
+        </p:txBody>
+      </p:sp>
+      <p:sp>
+        <p:nvSpPr>
+          <p:cNvPr id="9" name="TextBox 8"/>
           <p:cNvSpPr txBox="1"/>
           <p:nvPr/>
         </p:nvSpPr>
@@ -3555,7 +3589,7 @@
         <p:spPr>
           <a:xfrm>
             <a:off x="731520" y="1600200"/>
-            <a:ext cx="10698480" cy="960120"/>
+            <a:ext cx="10698480" cy="777240"/>
           </a:xfrm>
           <a:prstGeom prst="rect">
             <a:avLst/>
@@ -3570,7 +3604,7 @@
           <a:p>
             <a:pPr algn="l"/>
             <a:r>
-              <a:rPr sz="1700" b="0">
+              <a:rPr sz="1500" b="0">
                 <a:solidFill>
                   <a:srgbClr val="FFFFFF"/>
                 </a:solidFill>
@@ -3588,8 +3622,8 @@
         </p:nvSpPr>
         <p:spPr>
           <a:xfrm>
-            <a:off x="731520" y="2651760"/>
-            <a:ext cx="10698480" cy="960120"/>
+            <a:off x="731520" y="2468880"/>
+            <a:ext cx="10698480" cy="777240"/>
           </a:xfrm>
           <a:prstGeom prst="rect">
             <a:avLst/>
@@ -3604,7 +3638,7 @@
           <a:p>
             <a:pPr algn="l"/>
             <a:r>
-              <a:rPr sz="1700" b="0">
+              <a:rPr sz="1500" b="0">
                 <a:solidFill>
                   <a:srgbClr val="FFFFFF"/>
                 </a:solidFill>
@@ -3622,8 +3656,8 @@
         </p:nvSpPr>
         <p:spPr>
           <a:xfrm>
-            <a:off x="731520" y="3703320"/>
-            <a:ext cx="10698480" cy="960120"/>
+            <a:off x="731520" y="3337560"/>
+            <a:ext cx="10698480" cy="777240"/>
           </a:xfrm>
           <a:prstGeom prst="rect">
             <a:avLst/>
@@ -3638,7 +3672,7 @@
           <a:p>
             <a:pPr algn="l"/>
             <a:r>
-              <a:rPr sz="1700" b="0">
+              <a:rPr sz="1500" b="0">
                 <a:solidFill>
                   <a:srgbClr val="FFFFFF"/>
                 </a:solidFill>
@@ -3656,8 +3690,8 @@
         </p:nvSpPr>
         <p:spPr>
           <a:xfrm>
-            <a:off x="731520" y="4754880"/>
-            <a:ext cx="10698480" cy="960120"/>
+            <a:off x="731520" y="4206240"/>
+            <a:ext cx="10698480" cy="777240"/>
           </a:xfrm>
           <a:prstGeom prst="rect">
             <a:avLst/>
@@ -3672,7 +3706,7 @@
           <a:p>
             <a:pPr algn="l"/>
             <a:r>
-              <a:rPr sz="1700" b="0">
+              <a:rPr sz="1500" b="0">
                 <a:solidFill>
                   <a:srgbClr val="FFFFFF"/>
                 </a:solidFill>
@@ -3685,6 +3719,40 @@
       <p:sp>
         <p:nvSpPr>
           <p:cNvPr id="8" name="TextBox 7"/>
+          <p:cNvSpPr txBox="1"/>
+          <p:nvPr/>
+        </p:nvSpPr>
+        <p:spPr>
+          <a:xfrm>
+            <a:off x="731520" y="5074920"/>
+            <a:ext cx="10698480" cy="777240"/>
+          </a:xfrm>
+          <a:prstGeom prst="rect">
+            <a:avLst/>
+          </a:prstGeom>
+          <a:noFill/>
+        </p:spPr>
+        <p:txBody>
+          <a:bodyPr wrap="square">
+            <a:spAutoFit/>
+          </a:bodyPr>
+          <a:lstStyle/>
+          <a:p>
+            <a:pPr algn="l"/>
+            <a:r>
+              <a:rPr sz="1500" b="0">
+                <a:solidFill>
+                  <a:srgbClr val="FFFFFF"/>
+                </a:solidFill>
+              </a:rPr>
+              <a:t>  Codex CLI vs Cursor: the architectural difference</a:t>
+            </a:r>
+          </a:p>
+        </p:txBody>
+      </p:sp>
+      <p:sp>
+        <p:nvSpPr>
+          <p:cNvPr id="9" name="TextBox 8"/>
           <p:cNvSpPr txBox="1"/>
           <p:nvPr/>
         </p:nvSpPr>
@@ -3828,7 +3896,7 @@
         <p:spPr>
           <a:xfrm>
             <a:off x="731520" y="1600200"/>
-            <a:ext cx="10698480" cy="960120"/>
+            <a:ext cx="10698480" cy="777240"/>
           </a:xfrm>
           <a:prstGeom prst="rect">
             <a:avLst/>
@@ -3843,7 +3911,7 @@
           <a:p>
             <a:pPr algn="l"/>
             <a:r>
-              <a:rPr sz="1700" b="0">
+              <a:rPr sz="1500" b="0">
                 <a:solidFill>
                   <a:srgbClr val="FFFFFF"/>
                 </a:solidFill>
@@ -3861,8 +3929,8 @@
         </p:nvSpPr>
         <p:spPr>
           <a:xfrm>
-            <a:off x="731520" y="2651760"/>
-            <a:ext cx="10698480" cy="960120"/>
+            <a:off x="731520" y="2468880"/>
+            <a:ext cx="10698480" cy="777240"/>
           </a:xfrm>
           <a:prstGeom prst="rect">
             <a:avLst/>
@@ -3877,7 +3945,7 @@
           <a:p>
             <a:pPr algn="l"/>
             <a:r>
-              <a:rPr sz="1700" b="0">
+              <a:rPr sz="1500" b="0">
                 <a:solidFill>
                   <a:srgbClr val="FFFFFF"/>
                 </a:solidFill>
@@ -3895,8 +3963,8 @@
         </p:nvSpPr>
         <p:spPr>
           <a:xfrm>
-            <a:off x="731520" y="3703320"/>
-            <a:ext cx="10698480" cy="960120"/>
+            <a:off x="731520" y="3337560"/>
+            <a:ext cx="10698480" cy="777240"/>
           </a:xfrm>
           <a:prstGeom prst="rect">
             <a:avLst/>
@@ -3911,7 +3979,7 @@
           <a:p>
             <a:pPr algn="l"/>
             <a:r>
-              <a:rPr sz="1700" b="0">
+              <a:rPr sz="1500" b="0">
                 <a:solidFill>
                   <a:srgbClr val="FFFFFF"/>
                 </a:solidFill>
@@ -3929,8 +3997,8 @@
         </p:nvSpPr>
         <p:spPr>
           <a:xfrm>
-            <a:off x="731520" y="4754880"/>
-            <a:ext cx="10698480" cy="960120"/>
+            <a:off x="731520" y="4206240"/>
+            <a:ext cx="10698480" cy="777240"/>
           </a:xfrm>
           <a:prstGeom prst="rect">
             <a:avLst/>
@@ -3945,7 +4013,7 @@
           <a:p>
             <a:pPr algn="l"/>
             <a:r>
-              <a:rPr sz="1700" b="0">
+              <a:rPr sz="1500" b="0">
                 <a:solidFill>
                   <a:srgbClr val="FFFFFF"/>
                 </a:solidFill>
@@ -3958,6 +4026,40 @@
       <p:sp>
         <p:nvSpPr>
           <p:cNvPr id="8" name="TextBox 7"/>
+          <p:cNvSpPr txBox="1"/>
+          <p:nvPr/>
+        </p:nvSpPr>
+        <p:spPr>
+          <a:xfrm>
+            <a:off x="731520" y="5074920"/>
+            <a:ext cx="10698480" cy="777240"/>
+          </a:xfrm>
+          <a:prstGeom prst="rect">
+            <a:avLst/>
+          </a:prstGeom>
+          <a:noFill/>
+        </p:spPr>
+        <p:txBody>
+          <a:bodyPr wrap="square">
+            <a:spAutoFit/>
+          </a:bodyPr>
+          <a:lstStyle/>
+          <a:p>
+            <a:pPr algn="l"/>
+            <a:r>
+              <a:rPr sz="1500" b="0">
+                <a:solidFill>
+                  <a:srgbClr val="FFFFFF"/>
+                </a:solidFill>
+              </a:rPr>
+              <a:t>  MCP connectors — integrates with external services (databases, APIs, CI systems) via the Model Context Protocol</a:t>
+            </a:r>
+          </a:p>
+        </p:txBody>
+      </p:sp>
+      <p:sp>
+        <p:nvSpPr>
+          <p:cNvPr id="9" name="TextBox 8"/>
           <p:cNvSpPr txBox="1"/>
           <p:nvPr/>
         </p:nvSpPr>
@@ -4374,7 +4476,7 @@
         <p:spPr>
           <a:xfrm>
             <a:off x="731520" y="1600200"/>
-            <a:ext cx="10698480" cy="960120"/>
+            <a:ext cx="10698480" cy="777240"/>
           </a:xfrm>
           <a:prstGeom prst="rect">
             <a:avLst/>
@@ -4389,12 +4491,12 @@
           <a:p>
             <a:pPr algn="l"/>
             <a:r>
-              <a:rPr sz="1700" b="0">
+              <a:rPr sz="1500" b="0">
                 <a:solidFill>
                   <a:srgbClr val="FFFFFF"/>
                 </a:solidFill>
               </a:rPr>
-              <a:t>  A) They can schedule the Cursor terminal to run the command headlessly using a launchd plist that invokes Cursor</a:t>
+              <a:t>  Question 1 (MCQ): A developer uses Cursor's terminal Ctrl+K feature to generate a complex awk pipeline, tests it successfully in the IDE terminal, and wants to "automate it." Which statement is correct?</a:t>
             </a:r>
           </a:p>
         </p:txBody>
@@ -4407,8 +4509,8 @@
         </p:nvSpPr>
         <p:spPr>
           <a:xfrm>
-            <a:off x="731520" y="2651760"/>
-            <a:ext cx="10698480" cy="960120"/>
+            <a:off x="731520" y="2468880"/>
+            <a:ext cx="10698480" cy="777240"/>
           </a:xfrm>
           <a:prstGeom prst="rect">
             <a:avLst/>
@@ -4423,12 +4525,12 @@
           <a:p>
             <a:pPr algn="l"/>
             <a:r>
-              <a:rPr sz="1700" b="0">
+              <a:rPr sz="1500" b="0">
                 <a:solidFill>
                   <a:srgbClr val="FFFFFF"/>
                 </a:solidFill>
               </a:rPr>
-              <a:t>  C) Cursor's Background Agents can run the terminal command unattended as a scheduled task</a:t>
+              <a:t>  A) They can schedule the Cursor terminal to run the command headlessly using a launchd plist that invokes Cursor</a:t>
             </a:r>
           </a:p>
         </p:txBody>
@@ -4441,8 +4543,8 @@
         </p:nvSpPr>
         <p:spPr>
           <a:xfrm>
-            <a:off x="731520" y="3703320"/>
-            <a:ext cx="10698480" cy="960120"/>
+            <a:off x="731520" y="3337560"/>
+            <a:ext cx="10698480" cy="777240"/>
           </a:xfrm>
           <a:prstGeom prst="rect">
             <a:avLst/>
@@ -4457,7 +4559,75 @@
           <a:p>
             <a:pPr algn="l"/>
             <a:r>
-              <a:rPr sz="1700" b="0">
+              <a:rPr sz="1500" b="0">
+                <a:solidFill>
+                  <a:srgbClr val="FFFFFF"/>
+                </a:solidFill>
+              </a:rPr>
+              <a:t>  B) They should extract the generated shell command into a standalone script and invoke it via Codex CLI or a cron job — the Cursor terminal cannot run headlessly</a:t>
+            </a:r>
+          </a:p>
+        </p:txBody>
+      </p:sp>
+      <p:sp>
+        <p:nvSpPr>
+          <p:cNvPr id="7" name="TextBox 6"/>
+          <p:cNvSpPr txBox="1"/>
+          <p:nvPr/>
+        </p:nvSpPr>
+        <p:spPr>
+          <a:xfrm>
+            <a:off x="731520" y="4206240"/>
+            <a:ext cx="10698480" cy="777240"/>
+          </a:xfrm>
+          <a:prstGeom prst="rect">
+            <a:avLst/>
+          </a:prstGeom>
+          <a:noFill/>
+        </p:spPr>
+        <p:txBody>
+          <a:bodyPr wrap="square">
+            <a:spAutoFit/>
+          </a:bodyPr>
+          <a:lstStyle/>
+          <a:p>
+            <a:pPr algn="l"/>
+            <a:r>
+              <a:rPr sz="1500" b="0">
+                <a:solidFill>
+                  <a:srgbClr val="FFFFFF"/>
+                </a:solidFill>
+              </a:rPr>
+              <a:t>  C) Cursor's Background Agents can run the terminal command unattended as a scheduled task</a:t>
+            </a:r>
+          </a:p>
+        </p:txBody>
+      </p:sp>
+      <p:sp>
+        <p:nvSpPr>
+          <p:cNvPr id="8" name="TextBox 7"/>
+          <p:cNvSpPr txBox="1"/>
+          <p:nvPr/>
+        </p:nvSpPr>
+        <p:spPr>
+          <a:xfrm>
+            <a:off x="731520" y="5074920"/>
+            <a:ext cx="10698480" cy="777240"/>
+          </a:xfrm>
+          <a:prstGeom prst="rect">
+            <a:avLst/>
+          </a:prstGeom>
+          <a:noFill/>
+        </p:spPr>
+        <p:txBody>
+          <a:bodyPr wrap="square">
+            <a:spAutoFit/>
+          </a:bodyPr>
+          <a:lstStyle/>
+          <a:p>
+            <a:pPr algn="l"/>
+            <a:r>
+              <a:rPr sz="1500" b="0">
                 <a:solidFill>
                   <a:srgbClr val="FFFFFF"/>
                 </a:solidFill>
@@ -4469,7 +4639,7 @@
       </p:sp>
       <p:sp>
         <p:nvSpPr>
-          <p:cNvPr id="7" name="TextBox 6"/>
+          <p:cNvPr id="9" name="TextBox 8"/>
           <p:cNvSpPr txBox="1"/>
           <p:nvPr/>
         </p:nvSpPr>

</xml_diff>